<commit_message>
folien: praefix-tabelle mit halbierungs-balken und /29, aufgabe a als zahlenstrahl aufgeloest
</commit_message>
<xml_diff>
--- a/folien/dist/02-adressierung-subnetting.pptx
+++ b/folien/dist/02-adressierung-subnetting.pptx
@@ -4074,151 +4074,33 @@
           </a:p>
         </p:txBody>
       </p:sp>
-      <p:sp>
-        <p:nvSpPr>
-          <p:cNvPr id="9" name="Text 7"/>
-          <p:cNvSpPr/>
-          <p:nvPr/>
-        </p:nvSpPr>
-        <p:spPr>
-          <a:xfrm>
-            <a:off x="566928" y="2834640"/>
-            <a:ext cx="8010144" cy="1143000"/>
-          </a:xfrm>
-          <a:prstGeom prst="rect">
-            <a:avLst/>
-          </a:prstGeom>
-          <a:noFill/>
-          <a:ln/>
-        </p:spPr>
-        <p:txBody>
-          <a:bodyPr wrap="square" lIns="0" tIns="0" rIns="0" bIns="0" rtlCol="0" anchor="t"/>
-          <a:lstStyle/>
-          <a:p>
-            <a:pPr indent="0" marL="0">
-              <a:lnSpc>
-                <a:spcPct val="92000"/>
-              </a:lnSpc>
-              <a:buNone/>
-            </a:pPr>
-            <a:r>
-              <a:rPr lang="en-US" sz="1250" b="1" dirty="0">
-                <a:solidFill>
-                  <a:srgbClr val="0F7C86"/>
-                </a:solidFill>
-                <a:latin typeface="Arial" pitchFamily="34" charset="0"/>
-                <a:ea typeface="Arial" pitchFamily="34" charset="-122"/>
-                <a:cs typeface="Arial" pitchFamily="34" charset="-120"/>
-              </a:rPr>
-              <a:t>1   </a:t>
-            </a:r>
-            <a:pPr indent="0" marL="0">
-              <a:lnSpc>
-                <a:spcPct val="92000"/>
-              </a:lnSpc>
-              <a:spcAft>
-                <a:spcPts val="900"/>
-              </a:spcAft>
-              <a:buNone/>
-            </a:pPr>
-            <a:r>
-              <a:rPr lang="en-US" sz="1250" dirty="0">
-                <a:solidFill>
-                  <a:srgbClr val="434A63"/>
-                </a:solidFill>
-                <a:latin typeface="Arial" pitchFamily="34" charset="0"/>
-                <a:ea typeface="Arial" pitchFamily="34" charset="-122"/>
-                <a:cs typeface="Arial" pitchFamily="34" charset="-120"/>
-              </a:rPr>
-              <a:t>Blockgröße 64 → die Netze starten bei .0, .64, .128, .192</a:t>
-            </a:r>
-            <a:endParaRPr lang="en-US" sz="1250" dirty="0"/>
-          </a:p>
-          <a:p>
-            <a:pPr indent="0" marL="0">
-              <a:lnSpc>
-                <a:spcPct val="92000"/>
-              </a:lnSpc>
-              <a:buNone/>
-            </a:pPr>
-            <a:r>
-              <a:rPr lang="en-US" sz="1250" b="1" dirty="0">
-                <a:solidFill>
-                  <a:srgbClr val="0F7C86"/>
-                </a:solidFill>
-                <a:latin typeface="Arial" pitchFamily="34" charset="0"/>
-                <a:ea typeface="Arial" pitchFamily="34" charset="-122"/>
-                <a:cs typeface="Arial" pitchFamily="34" charset="-120"/>
-              </a:rPr>
-              <a:t>2   </a:t>
-            </a:r>
-            <a:pPr indent="0" marL="0">
-              <a:lnSpc>
-                <a:spcPct val="92000"/>
-              </a:lnSpc>
-              <a:spcAft>
-                <a:spcPts val="900"/>
-              </a:spcAft>
-              <a:buNone/>
-            </a:pPr>
-            <a:r>
-              <a:rPr lang="en-US" sz="1250" dirty="0">
-                <a:solidFill>
-                  <a:srgbClr val="434A63"/>
-                </a:solidFill>
-                <a:latin typeface="Arial" pitchFamily="34" charset="0"/>
-                <a:ea typeface="Arial" pitchFamily="34" charset="-122"/>
-                <a:cs typeface="Arial" pitchFamily="34" charset="-120"/>
-              </a:rPr>
-              <a:t>.77 liegt im Block ab .64 → Netzadresse 192.168.10.64</a:t>
-            </a:r>
-            <a:endParaRPr lang="en-US" sz="1250" dirty="0"/>
-          </a:p>
-          <a:p>
-            <a:pPr indent="0" marL="0">
-              <a:lnSpc>
-                <a:spcPct val="92000"/>
-              </a:lnSpc>
-              <a:buNone/>
-            </a:pPr>
-            <a:r>
-              <a:rPr lang="en-US" sz="1250" b="1" dirty="0">
-                <a:solidFill>
-                  <a:srgbClr val="0F7C86"/>
-                </a:solidFill>
-                <a:latin typeface="Arial" pitchFamily="34" charset="0"/>
-                <a:ea typeface="Arial" pitchFamily="34" charset="-122"/>
-                <a:cs typeface="Arial" pitchFamily="34" charset="-120"/>
-              </a:rPr>
-              <a:t>3   </a:t>
-            </a:r>
-            <a:pPr indent="0" marL="0">
-              <a:lnSpc>
-                <a:spcPct val="92000"/>
-              </a:lnSpc>
-              <a:spcAft>
-                <a:spcPts val="900"/>
-              </a:spcAft>
-              <a:buNone/>
-            </a:pPr>
-            <a:r>
-              <a:rPr lang="en-US" sz="1250" dirty="0">
-                <a:solidFill>
-                  <a:srgbClr val="434A63"/>
-                </a:solidFill>
-                <a:latin typeface="Arial" pitchFamily="34" charset="0"/>
-                <a:ea typeface="Arial" pitchFamily="34" charset="-122"/>
-                <a:cs typeface="Arial" pitchFamily="34" charset="-120"/>
-              </a:rPr>
-              <a:t>nutzbar .65 bis .126 · Broadcast .127</a:t>
-            </a:r>
-            <a:endParaRPr lang="en-US" sz="1250" dirty="0"/>
-          </a:p>
-        </p:txBody>
-      </p:sp>
-      <p:sp>
-        <p:nvSpPr>
-          <p:cNvPr id="10" name="Shape 8"/>
+      <p:pic>
+        <p:nvPicPr>
+          <p:cNvPr id="9" name="Image 0" descr="/Users/jacobmenge/Desktop/kurs-unterlagen/folien/assets/diagramme/block-strahl.png">    </p:cNvPr>
+          <p:cNvPicPr>
+            <a:picLocks noChangeAspect="1"/>
+          </p:cNvPicPr>
+          <p:nvPr/>
+        </p:nvPicPr>
+        <p:blipFill>
+          <a:blip r:embed="rId1"/>
+          <a:stretch>
+            <a:fillRect/>
+          </a:stretch>
+        </p:blipFill>
+        <p:spPr>
+          <a:xfrm>
+            <a:off x="566928" y="2788920"/>
+            <a:ext cx="8010144" cy="1115568"/>
+          </a:xfrm>
+          <a:prstGeom prst="rect">
+            <a:avLst/>
+          </a:prstGeom>
+        </p:spPr>
+      </p:pic>
+      <p:sp>
+        <p:nvSpPr>
+          <p:cNvPr id="10" name="Shape 7"/>
           <p:cNvSpPr/>
           <p:nvPr/>
         </p:nvSpPr>
@@ -4238,7 +4120,7 @@
       </p:sp>
       <p:sp>
         <p:nvSpPr>
-          <p:cNvPr id="11" name="Text 9"/>
+          <p:cNvPr id="11" name="Text 8"/>
           <p:cNvSpPr/>
           <p:nvPr/>
         </p:nvSpPr>
@@ -4269,7 +4151,7 @@
                 <a:ea typeface="Arial" pitchFamily="34" charset="-122"/>
                 <a:cs typeface="Arial" pitchFamily="34" charset="-120"/>
               </a:rPr>
-              <a:t>Der Blockanfang ist nie ein Gerät – er benennt das Netz.</a:t>
+              <a:t>Nutzbar .65 bis .126 – der Blockanfang benennt das Netz, die letzte Adresse ruft alle.</a:t>
             </a:r>
             <a:endParaRPr lang="en-US" sz="1200" dirty="0"/>
           </a:p>
@@ -4277,7 +4159,7 @@
       </p:sp>
       <p:sp>
         <p:nvSpPr>
-          <p:cNvPr id="12" name="Shape 10"/>
+          <p:cNvPr id="12" name="Shape 9"/>
           <p:cNvSpPr/>
           <p:nvPr/>
         </p:nvSpPr>
@@ -4300,7 +4182,7 @@
       </p:sp>
       <p:sp>
         <p:nvSpPr>
-          <p:cNvPr id="13" name="Text 11"/>
+          <p:cNvPr id="13" name="Text 10"/>
           <p:cNvSpPr/>
           <p:nvPr/>
         </p:nvSpPr>
@@ -4339,7 +4221,7 @@
       </p:sp>
       <p:sp>
         <p:nvSpPr>
-          <p:cNvPr id="14" name="Text 12"/>
+          <p:cNvPr id="14" name="Text 11"/>
           <p:cNvSpPr/>
           <p:nvPr/>
         </p:nvSpPr>
@@ -8909,7 +8791,7 @@
                 <a:ea typeface="Arial" pitchFamily="34" charset="-122"/>
                 <a:cs typeface="Arial" pitchFamily="34" charset="-120"/>
               </a:rPr>
-              <a:t>Die Müller GmbH zieht um. Ihr bekommt ein /24 und schneidet daraus die Abteilungsnetze – auf Papier, wie in der Prüfung.</a:t>
+              <a:t>Die Müller GmbH zieht um. Ihr bekommt ein /24 und schneidet daraus die Abteilungsnetze – nur mit Stift, Papier und dem Rezept von eben.</a:t>
             </a:r>
             <a:endParaRPr lang="en-US" sz="1300" dirty="0"/>
           </a:p>
@@ -14586,7 +14468,7 @@
         <p:spPr>
           <a:xfrm>
             <a:off x="566928" y="1444752"/>
-            <a:ext cx="8010144" cy="438912"/>
+            <a:ext cx="8010144" cy="274320"/>
           </a:xfrm>
           <a:prstGeom prst="rect">
             <a:avLst/>
@@ -14610,7 +14492,7 @@
                 <a:ea typeface="Arial" pitchFamily="34" charset="-122"/>
                 <a:cs typeface="Arial" pitchFamily="34" charset="-120"/>
               </a:rPr>
-              <a:t>Diese Tabelle ist euer Werkzeug für heute. Blockgröße = 2 hoch Hostbits.</a:t>
+              <a:t>Euer Werkzeug für heute. Blockgröße = 2 hoch Hostbits – jeder Schritt halbiert.</a:t>
             </a:r>
             <a:endParaRPr lang="en-US" sz="1300" dirty="0"/>
           </a:p>
@@ -14624,8 +14506,8 @@
         </p:nvSpPr>
         <p:spPr>
           <a:xfrm>
-            <a:off x="658368" y="1901952"/>
-            <a:ext cx="822960" cy="274320"/>
+            <a:off x="658368" y="1783080"/>
+            <a:ext cx="731520" cy="274320"/>
           </a:xfrm>
           <a:prstGeom prst="rect">
             <a:avLst/>
@@ -14663,8 +14545,8 @@
         </p:nvSpPr>
         <p:spPr>
           <a:xfrm>
-            <a:off x="1664208" y="1901952"/>
-            <a:ext cx="1920240" cy="274320"/>
+            <a:off x="1572768" y="1783080"/>
+            <a:ext cx="1737360" cy="274320"/>
           </a:xfrm>
           <a:prstGeom prst="rect">
             <a:avLst/>
@@ -14702,8 +14584,8 @@
         </p:nvSpPr>
         <p:spPr>
           <a:xfrm>
-            <a:off x="3767328" y="1901952"/>
-            <a:ext cx="4718304" cy="274320"/>
+            <a:off x="3493008" y="1783080"/>
+            <a:ext cx="2468880" cy="274320"/>
           </a:xfrm>
           <a:prstGeom prst="rect">
             <a:avLst/>
@@ -14727,7 +14609,7 @@
                 <a:ea typeface="Arial" pitchFamily="34" charset="-122"/>
                 <a:cs typeface="Arial" pitchFamily="34" charset="-120"/>
               </a:rPr>
-              <a:t>Blockgröße · nutzbare Geräte</a:t>
+              <a:t>Blockgröße · nutzbar</a:t>
             </a:r>
             <a:endParaRPr lang="en-US" sz="1050" dirty="0"/>
           </a:p>
@@ -14741,8 +14623,8 @@
         </p:nvSpPr>
         <p:spPr>
           <a:xfrm>
-            <a:off x="566928" y="2194560"/>
-            <a:ext cx="8010144" cy="0"/>
+            <a:off x="566928" y="2075688"/>
+            <a:ext cx="5486400" cy="0"/>
           </a:xfrm>
           <a:prstGeom prst="line">
             <a:avLst/>
@@ -14764,8 +14646,8 @@
         </p:nvSpPr>
         <p:spPr>
           <a:xfrm>
-            <a:off x="475488" y="2267712"/>
-            <a:ext cx="8193024" cy="301752"/>
+            <a:off x="475488" y="2148840"/>
+            <a:ext cx="5669280" cy="283464"/>
           </a:xfrm>
           <a:prstGeom prst="rect">
             <a:avLst/>
@@ -14784,8 +14666,8 @@
         </p:nvSpPr>
         <p:spPr>
           <a:xfrm>
-            <a:off x="658368" y="2267712"/>
-            <a:ext cx="822960" cy="301752"/>
+            <a:off x="658368" y="2148840"/>
+            <a:ext cx="731520" cy="283464"/>
           </a:xfrm>
           <a:prstGeom prst="rect">
             <a:avLst/>
@@ -14801,7 +14683,7 @@
               <a:buNone/>
             </a:pPr>
             <a:r>
-              <a:rPr lang="en-US" sz="1150" b="1" dirty="0">
+              <a:rPr lang="en-US" sz="1100" b="1" dirty="0">
                 <a:solidFill>
                   <a:srgbClr val="272E52"/>
                 </a:solidFill>
@@ -14811,7 +14693,7 @@
               </a:rPr>
               <a:t>/24</a:t>
             </a:r>
-            <a:endParaRPr lang="en-US" sz="1150" dirty="0"/>
+            <a:endParaRPr lang="en-US" sz="1100" dirty="0"/>
           </a:p>
         </p:txBody>
       </p:sp>
@@ -14823,8 +14705,8 @@
         </p:nvSpPr>
         <p:spPr>
           <a:xfrm>
-            <a:off x="1664208" y="2267712"/>
-            <a:ext cx="1920240" cy="301752"/>
+            <a:off x="1572768" y="2148840"/>
+            <a:ext cx="1737360" cy="283464"/>
           </a:xfrm>
           <a:prstGeom prst="rect">
             <a:avLst/>
@@ -14840,7 +14722,7 @@
               <a:buNone/>
             </a:pPr>
             <a:r>
-              <a:rPr lang="en-US" sz="1150" dirty="0">
+              <a:rPr lang="en-US" sz="1100" dirty="0">
                 <a:solidFill>
                   <a:srgbClr val="434A63"/>
                 </a:solidFill>
@@ -14850,7 +14732,7 @@
               </a:rPr>
               <a:t>255.255.255.0</a:t>
             </a:r>
-            <a:endParaRPr lang="en-US" sz="1150" dirty="0"/>
+            <a:endParaRPr lang="en-US" sz="1100" dirty="0"/>
           </a:p>
         </p:txBody>
       </p:sp>
@@ -14862,8 +14744,8 @@
         </p:nvSpPr>
         <p:spPr>
           <a:xfrm>
-            <a:off x="3767328" y="2267712"/>
-            <a:ext cx="4718304" cy="301752"/>
+            <a:off x="3493008" y="2148840"/>
+            <a:ext cx="2468880" cy="283464"/>
           </a:xfrm>
           <a:prstGeom prst="rect">
             <a:avLst/>
@@ -14879,7 +14761,7 @@
               <a:buNone/>
             </a:pPr>
             <a:r>
-              <a:rPr lang="en-US" sz="1150" dirty="0">
+              <a:rPr lang="en-US" sz="1100" dirty="0">
                 <a:solidFill>
                   <a:srgbClr val="434A63"/>
                 </a:solidFill>
@@ -14887,9 +14769,9 @@
                 <a:ea typeface="Arial" pitchFamily="34" charset="-122"/>
                 <a:cs typeface="Arial" pitchFamily="34" charset="-120"/>
               </a:rPr>
-              <a:t>256 Adressen · 254 Geräte</a:t>
-            </a:r>
-            <a:endParaRPr lang="en-US" sz="1150" dirty="0"/>
+              <a:t>256 · 254 Geräte</a:t>
+            </a:r>
+            <a:endParaRPr lang="en-US" sz="1100" dirty="0"/>
           </a:p>
         </p:txBody>
       </p:sp>
@@ -14901,8 +14783,8 @@
         </p:nvSpPr>
         <p:spPr>
           <a:xfrm>
-            <a:off x="658368" y="2569464"/>
-            <a:ext cx="822960" cy="301752"/>
+            <a:off x="658368" y="2432304"/>
+            <a:ext cx="731520" cy="283464"/>
           </a:xfrm>
           <a:prstGeom prst="rect">
             <a:avLst/>
@@ -14918,7 +14800,7 @@
               <a:buNone/>
             </a:pPr>
             <a:r>
-              <a:rPr lang="en-US" sz="1150" b="1" dirty="0">
+              <a:rPr lang="en-US" sz="1100" b="1" dirty="0">
                 <a:solidFill>
                   <a:srgbClr val="272E52"/>
                 </a:solidFill>
@@ -14928,7 +14810,7 @@
               </a:rPr>
               <a:t>/25</a:t>
             </a:r>
-            <a:endParaRPr lang="en-US" sz="1150" dirty="0"/>
+            <a:endParaRPr lang="en-US" sz="1100" dirty="0"/>
           </a:p>
         </p:txBody>
       </p:sp>
@@ -14940,8 +14822,8 @@
         </p:nvSpPr>
         <p:spPr>
           <a:xfrm>
-            <a:off x="1664208" y="2569464"/>
-            <a:ext cx="1920240" cy="301752"/>
+            <a:off x="1572768" y="2432304"/>
+            <a:ext cx="1737360" cy="283464"/>
           </a:xfrm>
           <a:prstGeom prst="rect">
             <a:avLst/>
@@ -14957,7 +14839,7 @@
               <a:buNone/>
             </a:pPr>
             <a:r>
-              <a:rPr lang="en-US" sz="1150" dirty="0">
+              <a:rPr lang="en-US" sz="1100" dirty="0">
                 <a:solidFill>
                   <a:srgbClr val="434A63"/>
                 </a:solidFill>
@@ -14967,7 +14849,7 @@
               </a:rPr>
               <a:t>255.255.255.128</a:t>
             </a:r>
-            <a:endParaRPr lang="en-US" sz="1150" dirty="0"/>
+            <a:endParaRPr lang="en-US" sz="1100" dirty="0"/>
           </a:p>
         </p:txBody>
       </p:sp>
@@ -14979,8 +14861,8 @@
         </p:nvSpPr>
         <p:spPr>
           <a:xfrm>
-            <a:off x="3767328" y="2569464"/>
-            <a:ext cx="4718304" cy="301752"/>
+            <a:off x="3493008" y="2432304"/>
+            <a:ext cx="2468880" cy="283464"/>
           </a:xfrm>
           <a:prstGeom prst="rect">
             <a:avLst/>
@@ -14996,7 +14878,7 @@
               <a:buNone/>
             </a:pPr>
             <a:r>
-              <a:rPr lang="en-US" sz="1150" dirty="0">
+              <a:rPr lang="en-US" sz="1100" dirty="0">
                 <a:solidFill>
                   <a:srgbClr val="434A63"/>
                 </a:solidFill>
@@ -15004,9 +14886,9 @@
                 <a:ea typeface="Arial" pitchFamily="34" charset="-122"/>
                 <a:cs typeface="Arial" pitchFamily="34" charset="-120"/>
               </a:rPr>
-              <a:t>128 Adressen · 126 Geräte</a:t>
-            </a:r>
-            <a:endParaRPr lang="en-US" sz="1150" dirty="0"/>
+              <a:t>128 · 126 Geräte</a:t>
+            </a:r>
+            <a:endParaRPr lang="en-US" sz="1100" dirty="0"/>
           </a:p>
         </p:txBody>
       </p:sp>
@@ -15018,8 +14900,8 @@
         </p:nvSpPr>
         <p:spPr>
           <a:xfrm>
-            <a:off x="475488" y="2871216"/>
-            <a:ext cx="8193024" cy="301752"/>
+            <a:off x="475488" y="2715768"/>
+            <a:ext cx="5669280" cy="283464"/>
           </a:xfrm>
           <a:prstGeom prst="rect">
             <a:avLst/>
@@ -15038,8 +14920,8 @@
         </p:nvSpPr>
         <p:spPr>
           <a:xfrm>
-            <a:off x="658368" y="2871216"/>
-            <a:ext cx="822960" cy="301752"/>
+            <a:off x="658368" y="2715768"/>
+            <a:ext cx="731520" cy="283464"/>
           </a:xfrm>
           <a:prstGeom prst="rect">
             <a:avLst/>
@@ -15055,7 +14937,7 @@
               <a:buNone/>
             </a:pPr>
             <a:r>
-              <a:rPr lang="en-US" sz="1150" b="1" dirty="0">
+              <a:rPr lang="en-US" sz="1100" b="1" dirty="0">
                 <a:solidFill>
                   <a:srgbClr val="272E52"/>
                 </a:solidFill>
@@ -15065,7 +14947,7 @@
               </a:rPr>
               <a:t>/26</a:t>
             </a:r>
-            <a:endParaRPr lang="en-US" sz="1150" dirty="0"/>
+            <a:endParaRPr lang="en-US" sz="1100" dirty="0"/>
           </a:p>
         </p:txBody>
       </p:sp>
@@ -15077,8 +14959,8 @@
         </p:nvSpPr>
         <p:spPr>
           <a:xfrm>
-            <a:off x="1664208" y="2871216"/>
-            <a:ext cx="1920240" cy="301752"/>
+            <a:off x="1572768" y="2715768"/>
+            <a:ext cx="1737360" cy="283464"/>
           </a:xfrm>
           <a:prstGeom prst="rect">
             <a:avLst/>
@@ -15094,7 +14976,7 @@
               <a:buNone/>
             </a:pPr>
             <a:r>
-              <a:rPr lang="en-US" sz="1150" dirty="0">
+              <a:rPr lang="en-US" sz="1100" dirty="0">
                 <a:solidFill>
                   <a:srgbClr val="434A63"/>
                 </a:solidFill>
@@ -15104,7 +14986,7 @@
               </a:rPr>
               <a:t>255.255.255.192</a:t>
             </a:r>
-            <a:endParaRPr lang="en-US" sz="1150" dirty="0"/>
+            <a:endParaRPr lang="en-US" sz="1100" dirty="0"/>
           </a:p>
         </p:txBody>
       </p:sp>
@@ -15116,8 +14998,8 @@
         </p:nvSpPr>
         <p:spPr>
           <a:xfrm>
-            <a:off x="3767328" y="2871216"/>
-            <a:ext cx="4718304" cy="301752"/>
+            <a:off x="3493008" y="2715768"/>
+            <a:ext cx="2468880" cy="283464"/>
           </a:xfrm>
           <a:prstGeom prst="rect">
             <a:avLst/>
@@ -15133,7 +15015,7 @@
               <a:buNone/>
             </a:pPr>
             <a:r>
-              <a:rPr lang="en-US" sz="1150" dirty="0">
+              <a:rPr lang="en-US" sz="1100" dirty="0">
                 <a:solidFill>
                   <a:srgbClr val="434A63"/>
                 </a:solidFill>
@@ -15141,9 +15023,9 @@
                 <a:ea typeface="Arial" pitchFamily="34" charset="-122"/>
                 <a:cs typeface="Arial" pitchFamily="34" charset="-120"/>
               </a:rPr>
-              <a:t>64 Adressen · 62 Geräte</a:t>
-            </a:r>
-            <a:endParaRPr lang="en-US" sz="1150" dirty="0"/>
+              <a:t>64 · 62 Geräte</a:t>
+            </a:r>
+            <a:endParaRPr lang="en-US" sz="1100" dirty="0"/>
           </a:p>
         </p:txBody>
       </p:sp>
@@ -15155,8 +15037,8 @@
         </p:nvSpPr>
         <p:spPr>
           <a:xfrm>
-            <a:off x="658368" y="3172968"/>
-            <a:ext cx="822960" cy="301752"/>
+            <a:off x="658368" y="2999232"/>
+            <a:ext cx="731520" cy="283464"/>
           </a:xfrm>
           <a:prstGeom prst="rect">
             <a:avLst/>
@@ -15172,7 +15054,7 @@
               <a:buNone/>
             </a:pPr>
             <a:r>
-              <a:rPr lang="en-US" sz="1150" b="1" dirty="0">
+              <a:rPr lang="en-US" sz="1100" b="1" dirty="0">
                 <a:solidFill>
                   <a:srgbClr val="272E52"/>
                 </a:solidFill>
@@ -15182,7 +15064,7 @@
               </a:rPr>
               <a:t>/27</a:t>
             </a:r>
-            <a:endParaRPr lang="en-US" sz="1150" dirty="0"/>
+            <a:endParaRPr lang="en-US" sz="1100" dirty="0"/>
           </a:p>
         </p:txBody>
       </p:sp>
@@ -15194,8 +15076,8 @@
         </p:nvSpPr>
         <p:spPr>
           <a:xfrm>
-            <a:off x="1664208" y="3172968"/>
-            <a:ext cx="1920240" cy="301752"/>
+            <a:off x="1572768" y="2999232"/>
+            <a:ext cx="1737360" cy="283464"/>
           </a:xfrm>
           <a:prstGeom prst="rect">
             <a:avLst/>
@@ -15211,7 +15093,7 @@
               <a:buNone/>
             </a:pPr>
             <a:r>
-              <a:rPr lang="en-US" sz="1150" dirty="0">
+              <a:rPr lang="en-US" sz="1100" dirty="0">
                 <a:solidFill>
                   <a:srgbClr val="434A63"/>
                 </a:solidFill>
@@ -15221,7 +15103,7 @@
               </a:rPr>
               <a:t>255.255.255.224</a:t>
             </a:r>
-            <a:endParaRPr lang="en-US" sz="1150" dirty="0"/>
+            <a:endParaRPr lang="en-US" sz="1100" dirty="0"/>
           </a:p>
         </p:txBody>
       </p:sp>
@@ -15233,8 +15115,8 @@
         </p:nvSpPr>
         <p:spPr>
           <a:xfrm>
-            <a:off x="3767328" y="3172968"/>
-            <a:ext cx="4718304" cy="301752"/>
+            <a:off x="3493008" y="2999232"/>
+            <a:ext cx="2468880" cy="283464"/>
           </a:xfrm>
           <a:prstGeom prst="rect">
             <a:avLst/>
@@ -15250,7 +15132,7 @@
               <a:buNone/>
             </a:pPr>
             <a:r>
-              <a:rPr lang="en-US" sz="1150" dirty="0">
+              <a:rPr lang="en-US" sz="1100" dirty="0">
                 <a:solidFill>
                   <a:srgbClr val="434A63"/>
                 </a:solidFill>
@@ -15258,9 +15140,9 @@
                 <a:ea typeface="Arial" pitchFamily="34" charset="-122"/>
                 <a:cs typeface="Arial" pitchFamily="34" charset="-120"/>
               </a:rPr>
-              <a:t>32 Adressen · 30 Geräte</a:t>
-            </a:r>
-            <a:endParaRPr lang="en-US" sz="1150" dirty="0"/>
+              <a:t>32 · 30 Geräte</a:t>
+            </a:r>
+            <a:endParaRPr lang="en-US" sz="1100" dirty="0"/>
           </a:p>
         </p:txBody>
       </p:sp>
@@ -15272,8 +15154,8 @@
         </p:nvSpPr>
         <p:spPr>
           <a:xfrm>
-            <a:off x="475488" y="3474720"/>
-            <a:ext cx="8193024" cy="301752"/>
+            <a:off x="475488" y="3282696"/>
+            <a:ext cx="5669280" cy="283464"/>
           </a:xfrm>
           <a:prstGeom prst="rect">
             <a:avLst/>
@@ -15292,8 +15174,8 @@
         </p:nvSpPr>
         <p:spPr>
           <a:xfrm>
-            <a:off x="658368" y="3474720"/>
-            <a:ext cx="822960" cy="301752"/>
+            <a:off x="658368" y="3282696"/>
+            <a:ext cx="731520" cy="283464"/>
           </a:xfrm>
           <a:prstGeom prst="rect">
             <a:avLst/>
@@ -15309,7 +15191,7 @@
               <a:buNone/>
             </a:pPr>
             <a:r>
-              <a:rPr lang="en-US" sz="1150" b="1" dirty="0">
+              <a:rPr lang="en-US" sz="1100" b="1" dirty="0">
                 <a:solidFill>
                   <a:srgbClr val="272E52"/>
                 </a:solidFill>
@@ -15319,7 +15201,7 @@
               </a:rPr>
               <a:t>/28</a:t>
             </a:r>
-            <a:endParaRPr lang="en-US" sz="1150" dirty="0"/>
+            <a:endParaRPr lang="en-US" sz="1100" dirty="0"/>
           </a:p>
         </p:txBody>
       </p:sp>
@@ -15331,8 +15213,8 @@
         </p:nvSpPr>
         <p:spPr>
           <a:xfrm>
-            <a:off x="1664208" y="3474720"/>
-            <a:ext cx="1920240" cy="301752"/>
+            <a:off x="1572768" y="3282696"/>
+            <a:ext cx="1737360" cy="283464"/>
           </a:xfrm>
           <a:prstGeom prst="rect">
             <a:avLst/>
@@ -15348,7 +15230,7 @@
               <a:buNone/>
             </a:pPr>
             <a:r>
-              <a:rPr lang="en-US" sz="1150" dirty="0">
+              <a:rPr lang="en-US" sz="1100" dirty="0">
                 <a:solidFill>
                   <a:srgbClr val="434A63"/>
                 </a:solidFill>
@@ -15358,7 +15240,7 @@
               </a:rPr>
               <a:t>255.255.255.240</a:t>
             </a:r>
-            <a:endParaRPr lang="en-US" sz="1150" dirty="0"/>
+            <a:endParaRPr lang="en-US" sz="1100" dirty="0"/>
           </a:p>
         </p:txBody>
       </p:sp>
@@ -15370,8 +15252,8 @@
         </p:nvSpPr>
         <p:spPr>
           <a:xfrm>
-            <a:off x="3767328" y="3474720"/>
-            <a:ext cx="4718304" cy="301752"/>
+            <a:off x="3493008" y="3282696"/>
+            <a:ext cx="2468880" cy="283464"/>
           </a:xfrm>
           <a:prstGeom prst="rect">
             <a:avLst/>
@@ -15387,7 +15269,7 @@
               <a:buNone/>
             </a:pPr>
             <a:r>
-              <a:rPr lang="en-US" sz="1150" dirty="0">
+              <a:rPr lang="en-US" sz="1100" dirty="0">
                 <a:solidFill>
                   <a:srgbClr val="434A63"/>
                 </a:solidFill>
@@ -15395,9 +15277,9 @@
                 <a:ea typeface="Arial" pitchFamily="34" charset="-122"/>
                 <a:cs typeface="Arial" pitchFamily="34" charset="-120"/>
               </a:rPr>
-              <a:t>16 Adressen · 14 Geräte</a:t>
-            </a:r>
-            <a:endParaRPr lang="en-US" sz="1150" dirty="0"/>
+              <a:t>16 · 14 Geräte</a:t>
+            </a:r>
+            <a:endParaRPr lang="en-US" sz="1100" dirty="0"/>
           </a:p>
         </p:txBody>
       </p:sp>
@@ -15409,8 +15291,8 @@
         </p:nvSpPr>
         <p:spPr>
           <a:xfrm>
-            <a:off x="658368" y="3776472"/>
-            <a:ext cx="822960" cy="301752"/>
+            <a:off x="658368" y="3566160"/>
+            <a:ext cx="731520" cy="283464"/>
           </a:xfrm>
           <a:prstGeom prst="rect">
             <a:avLst/>
@@ -15426,7 +15308,7 @@
               <a:buNone/>
             </a:pPr>
             <a:r>
-              <a:rPr lang="en-US" sz="1150" b="1" dirty="0">
+              <a:rPr lang="en-US" sz="1100" b="1" dirty="0">
                 <a:solidFill>
                   <a:srgbClr val="272E52"/>
                 </a:solidFill>
@@ -15434,22 +15316,159 @@
                 <a:ea typeface="Arial" pitchFamily="34" charset="-122"/>
                 <a:cs typeface="Arial" pitchFamily="34" charset="-120"/>
               </a:rPr>
+              <a:t>/29</a:t>
+            </a:r>
+            <a:endParaRPr lang="en-US" sz="1100" dirty="0"/>
+          </a:p>
+        </p:txBody>
+      </p:sp>
+      <p:sp>
+        <p:nvSpPr>
+          <p:cNvPr id="29" name="Text 27"/>
+          <p:cNvSpPr/>
+          <p:nvPr/>
+        </p:nvSpPr>
+        <p:spPr>
+          <a:xfrm>
+            <a:off x="1572768" y="3566160"/>
+            <a:ext cx="1737360" cy="283464"/>
+          </a:xfrm>
+          <a:prstGeom prst="rect">
+            <a:avLst/>
+          </a:prstGeom>
+          <a:noFill/>
+          <a:ln/>
+        </p:spPr>
+        <p:txBody>
+          <a:bodyPr wrap="square" lIns="0" tIns="0" rIns="0" bIns="0" rtlCol="0" anchor="ctr"/>
+          <a:lstStyle/>
+          <a:p>
+            <a:pPr indent="0" marL="0">
+              <a:buNone/>
+            </a:pPr>
+            <a:r>
+              <a:rPr lang="en-US" sz="1100" dirty="0">
+                <a:solidFill>
+                  <a:srgbClr val="434A63"/>
+                </a:solidFill>
+                <a:latin typeface="Arial" pitchFamily="34" charset="0"/>
+                <a:ea typeface="Arial" pitchFamily="34" charset="-122"/>
+                <a:cs typeface="Arial" pitchFamily="34" charset="-120"/>
+              </a:rPr>
+              <a:t>255.255.255.248</a:t>
+            </a:r>
+            <a:endParaRPr lang="en-US" sz="1100" dirty="0"/>
+          </a:p>
+        </p:txBody>
+      </p:sp>
+      <p:sp>
+        <p:nvSpPr>
+          <p:cNvPr id="30" name="Text 28"/>
+          <p:cNvSpPr/>
+          <p:nvPr/>
+        </p:nvSpPr>
+        <p:spPr>
+          <a:xfrm>
+            <a:off x="3493008" y="3566160"/>
+            <a:ext cx="2468880" cy="283464"/>
+          </a:xfrm>
+          <a:prstGeom prst="rect">
+            <a:avLst/>
+          </a:prstGeom>
+          <a:noFill/>
+          <a:ln/>
+        </p:spPr>
+        <p:txBody>
+          <a:bodyPr wrap="square" lIns="0" tIns="0" rIns="0" bIns="0" rtlCol="0" anchor="ctr"/>
+          <a:lstStyle/>
+          <a:p>
+            <a:pPr indent="0" marL="0">
+              <a:buNone/>
+            </a:pPr>
+            <a:r>
+              <a:rPr lang="en-US" sz="1100" dirty="0">
+                <a:solidFill>
+                  <a:srgbClr val="434A63"/>
+                </a:solidFill>
+                <a:latin typeface="Arial" pitchFamily="34" charset="0"/>
+                <a:ea typeface="Arial" pitchFamily="34" charset="-122"/>
+                <a:cs typeface="Arial" pitchFamily="34" charset="-120"/>
+              </a:rPr>
+              <a:t>8 · 6 Geräte</a:t>
+            </a:r>
+            <a:endParaRPr lang="en-US" sz="1100" dirty="0"/>
+          </a:p>
+        </p:txBody>
+      </p:sp>
+      <p:sp>
+        <p:nvSpPr>
+          <p:cNvPr id="31" name="Shape 29"/>
+          <p:cNvSpPr/>
+          <p:nvPr/>
+        </p:nvSpPr>
+        <p:spPr>
+          <a:xfrm>
+            <a:off x="475488" y="3849624"/>
+            <a:ext cx="5669280" cy="283464"/>
+          </a:xfrm>
+          <a:prstGeom prst="rect">
+            <a:avLst/>
+          </a:prstGeom>
+          <a:solidFill>
+            <a:srgbClr val="F5F6FC"/>
+          </a:solidFill>
+          <a:ln/>
+        </p:spPr>
+      </p:sp>
+      <p:sp>
+        <p:nvSpPr>
+          <p:cNvPr id="32" name="Text 30"/>
+          <p:cNvSpPr/>
+          <p:nvPr/>
+        </p:nvSpPr>
+        <p:spPr>
+          <a:xfrm>
+            <a:off x="658368" y="3849624"/>
+            <a:ext cx="731520" cy="283464"/>
+          </a:xfrm>
+          <a:prstGeom prst="rect">
+            <a:avLst/>
+          </a:prstGeom>
+          <a:noFill/>
+          <a:ln/>
+        </p:spPr>
+        <p:txBody>
+          <a:bodyPr wrap="square" lIns="0" tIns="0" rIns="0" bIns="0" rtlCol="0" anchor="ctr"/>
+          <a:lstStyle/>
+          <a:p>
+            <a:pPr indent="0" marL="0">
+              <a:buNone/>
+            </a:pPr>
+            <a:r>
+              <a:rPr lang="en-US" sz="1100" b="1" dirty="0">
+                <a:solidFill>
+                  <a:srgbClr val="272E52"/>
+                </a:solidFill>
+                <a:latin typeface="Arial" pitchFamily="34" charset="0"/>
+                <a:ea typeface="Arial" pitchFamily="34" charset="-122"/>
+                <a:cs typeface="Arial" pitchFamily="34" charset="-120"/>
+              </a:rPr>
               <a:t>/30</a:t>
             </a:r>
-            <a:endParaRPr lang="en-US" sz="1150" dirty="0"/>
-          </a:p>
-        </p:txBody>
-      </p:sp>
-      <p:sp>
-        <p:nvSpPr>
-          <p:cNvPr id="29" name="Text 27"/>
-          <p:cNvSpPr/>
-          <p:nvPr/>
-        </p:nvSpPr>
-        <p:spPr>
-          <a:xfrm>
-            <a:off x="1664208" y="3776472"/>
-            <a:ext cx="1920240" cy="301752"/>
+            <a:endParaRPr lang="en-US" sz="1100" dirty="0"/>
+          </a:p>
+        </p:txBody>
+      </p:sp>
+      <p:sp>
+        <p:nvSpPr>
+          <p:cNvPr id="33" name="Text 31"/>
+          <p:cNvSpPr/>
+          <p:nvPr/>
+        </p:nvSpPr>
+        <p:spPr>
+          <a:xfrm>
+            <a:off x="1572768" y="3849624"/>
+            <a:ext cx="1737360" cy="283464"/>
           </a:xfrm>
           <a:prstGeom prst="rect">
             <a:avLst/>
@@ -15465,7 +15484,7 @@
               <a:buNone/>
             </a:pPr>
             <a:r>
-              <a:rPr lang="en-US" sz="1150" dirty="0">
+              <a:rPr lang="en-US" sz="1100" dirty="0">
                 <a:solidFill>
                   <a:srgbClr val="434A63"/>
                 </a:solidFill>
@@ -15475,20 +15494,20 @@
               </a:rPr>
               <a:t>255.255.255.252</a:t>
             </a:r>
-            <a:endParaRPr lang="en-US" sz="1150" dirty="0"/>
-          </a:p>
-        </p:txBody>
-      </p:sp>
-      <p:sp>
-        <p:nvSpPr>
-          <p:cNvPr id="30" name="Text 28"/>
-          <p:cNvSpPr/>
-          <p:nvPr/>
-        </p:nvSpPr>
-        <p:spPr>
-          <a:xfrm>
-            <a:off x="3767328" y="3776472"/>
-            <a:ext cx="4718304" cy="301752"/>
+            <a:endParaRPr lang="en-US" sz="1100" dirty="0"/>
+          </a:p>
+        </p:txBody>
+      </p:sp>
+      <p:sp>
+        <p:nvSpPr>
+          <p:cNvPr id="34" name="Text 32"/>
+          <p:cNvSpPr/>
+          <p:nvPr/>
+        </p:nvSpPr>
+        <p:spPr>
+          <a:xfrm>
+            <a:off x="3493008" y="3849624"/>
+            <a:ext cx="2468880" cy="283464"/>
           </a:xfrm>
           <a:prstGeom prst="rect">
             <a:avLst/>
@@ -15504,7 +15523,7 @@
               <a:buNone/>
             </a:pPr>
             <a:r>
-              <a:rPr lang="en-US" sz="1150" dirty="0">
+              <a:rPr lang="en-US" sz="1100" dirty="0">
                 <a:solidFill>
                   <a:srgbClr val="434A63"/>
                 </a:solidFill>
@@ -15512,21 +15531,84 @@
                 <a:ea typeface="Arial" pitchFamily="34" charset="-122"/>
                 <a:cs typeface="Arial" pitchFamily="34" charset="-120"/>
               </a:rPr>
-              <a:t>4 Adressen · 2 Geräte – klassisch für Router-Kopplungen</a:t>
-            </a:r>
-            <a:endParaRPr lang="en-US" sz="1150" dirty="0"/>
-          </a:p>
-        </p:txBody>
-      </p:sp>
-      <p:sp>
-        <p:nvSpPr>
-          <p:cNvPr id="31" name="Shape 29"/>
-          <p:cNvSpPr/>
-          <p:nvPr/>
-        </p:nvSpPr>
-        <p:spPr>
-          <a:xfrm>
-            <a:off x="566928" y="4215384"/>
+              <a:t>4 · 2 – Router-Kopplung</a:t>
+            </a:r>
+            <a:endParaRPr lang="en-US" sz="1100" dirty="0"/>
+          </a:p>
+        </p:txBody>
+      </p:sp>
+      <p:sp>
+        <p:nvSpPr>
+          <p:cNvPr id="35" name="Text 33"/>
+          <p:cNvSpPr/>
+          <p:nvPr/>
+        </p:nvSpPr>
+        <p:spPr>
+          <a:xfrm>
+            <a:off x="6272784" y="1783080"/>
+            <a:ext cx="2304288" cy="274320"/>
+          </a:xfrm>
+          <a:prstGeom prst="rect">
+            <a:avLst/>
+          </a:prstGeom>
+          <a:noFill/>
+          <a:ln/>
+        </p:spPr>
+        <p:txBody>
+          <a:bodyPr wrap="square" lIns="0" tIns="0" rIns="0" bIns="0" rtlCol="0" anchor="ctr"/>
+          <a:lstStyle/>
+          <a:p>
+            <a:pPr indent="0" marL="0">
+              <a:buNone/>
+            </a:pPr>
+            <a:r>
+              <a:rPr lang="en-US" sz="1050" b="1" spc="80" kern="0" dirty="0">
+                <a:solidFill>
+                  <a:srgbClr val="0F7C86"/>
+                </a:solidFill>
+                <a:latin typeface="Arial" pitchFamily="34" charset="0"/>
+                <a:ea typeface="Arial" pitchFamily="34" charset="-122"/>
+                <a:cs typeface="Arial" pitchFamily="34" charset="-120"/>
+              </a:rPr>
+              <a:t>SO OFT PASST DER BLOCK INS /24</a:t>
+            </a:r>
+            <a:endParaRPr lang="en-US" sz="1050" dirty="0"/>
+          </a:p>
+        </p:txBody>
+      </p:sp>
+      <p:pic>
+        <p:nvPicPr>
+          <p:cNvPr id="36" name="Image 0" descr="/Users/jacobmenge/Desktop/kurs-unterlagen/folien/assets/diagramme/praefix-balken.png">    </p:cNvPr>
+          <p:cNvPicPr>
+            <a:picLocks noChangeAspect="1"/>
+          </p:cNvPicPr>
+          <p:nvPr/>
+        </p:nvPicPr>
+        <p:blipFill>
+          <a:blip r:embed="rId1"/>
+          <a:stretch>
+            <a:fillRect/>
+          </a:stretch>
+        </p:blipFill>
+        <p:spPr>
+          <a:xfrm>
+            <a:off x="6272784" y="2148840"/>
+            <a:ext cx="2304288" cy="1984248"/>
+          </a:xfrm>
+          <a:prstGeom prst="rect">
+            <a:avLst/>
+          </a:prstGeom>
+        </p:spPr>
+      </p:pic>
+      <p:sp>
+        <p:nvSpPr>
+          <p:cNvPr id="37" name="Shape 34"/>
+          <p:cNvSpPr/>
+          <p:nvPr/>
+        </p:nvSpPr>
+        <p:spPr>
+          <a:xfrm>
+            <a:off x="566928" y="4251960"/>
             <a:ext cx="32004" cy="256032"/>
           </a:xfrm>
           <a:prstGeom prst="rect">
@@ -15540,13 +15622,13 @@
       </p:sp>
       <p:sp>
         <p:nvSpPr>
-          <p:cNvPr id="32" name="Text 30"/>
-          <p:cNvSpPr/>
-          <p:nvPr/>
-        </p:nvSpPr>
-        <p:spPr>
-          <a:xfrm>
-            <a:off x="749808" y="4169664"/>
+          <p:cNvPr id="38" name="Text 35"/>
+          <p:cNvSpPr/>
+          <p:nvPr/>
+        </p:nvSpPr>
+        <p:spPr>
+          <a:xfrm>
+            <a:off x="749808" y="4206240"/>
             <a:ext cx="7827264" cy="402336"/>
           </a:xfrm>
           <a:prstGeom prst="rect">
@@ -15579,7 +15661,7 @@
       </p:sp>
       <p:sp>
         <p:nvSpPr>
-          <p:cNvPr id="33" name="Shape 31"/>
+          <p:cNvPr id="39" name="Shape 36"/>
           <p:cNvSpPr/>
           <p:nvPr/>
         </p:nvSpPr>
@@ -15602,7 +15684,7 @@
       </p:sp>
       <p:sp>
         <p:nvSpPr>
-          <p:cNvPr id="34" name="Text 32"/>
+          <p:cNvPr id="40" name="Text 37"/>
           <p:cNvSpPr/>
           <p:nvPr/>
         </p:nvSpPr>
@@ -15641,7 +15723,7 @@
       </p:sp>
       <p:sp>
         <p:nvSpPr>
-          <p:cNvPr id="35" name="Text 33"/>
+          <p:cNvPr id="41" name="Text 38"/>
           <p:cNvSpPr/>
           <p:nvPr/>
         </p:nvSpPr>
@@ -16930,7 +17012,7 @@
                 <a:ea typeface="Arial" pitchFamily="34" charset="-122"/>
                 <a:cs typeface="Arial" pitchFamily="34" charset="-120"/>
               </a:rPr>
-              <a:t>Mit diesen vier Schritten löst ihr jede Aufgabe von heute – und die aus der Prüfung gleich mit.</a:t>
+              <a:t>Mit diesen vier Schritten löst ihr jede Aufgabe von heute – und jede, die euch draußen begegnet.</a:t>
             </a:r>
             <a:endParaRPr lang="en-US" sz="1200" dirty="0"/>
           </a:p>

</xml_diff>